<commit_message>
Update PPT with Project Links and Resources slide
</commit_message>
<xml_diff>
--- a/News_Classification_Short.pptx
+++ b/News_Classification_Short.pptx
@@ -9,6 +9,7 @@
     <p:sldId id="257" r:id="rId8"/>
     <p:sldId id="258" r:id="rId9"/>
     <p:sldId id="259" r:id="rId10"/>
+    <p:sldId id="260" r:id="rId11"/>
   </p:sldIdLst>
   <p:sldSz cx="12191695" cy="6858000" type="screen4x3"/>
   <p:notesSz cx="6858000" cy="9144000"/>
@@ -4688,6 +4689,333 @@
             </a:pPr>
             <a:r>
               <a:t>The transition from manual tagging to Hugging Face Transformers eliminates processing bottlenecks and drastically reduces operational costs across publishing and finance sectors.</a:t>
+            </a:r>
+          </a:p>
+        </p:txBody>
+      </p:sp>
+    </p:spTree>
+  </p:cSld>
+  <p:clrMapOvr>
+    <a:masterClrMapping/>
+  </p:clrMapOvr>
+</p:sld>
+</file>
+
+<file path=ppt/slides/slide5.xml><?xml version="1.0" encoding="utf-8"?>
+<p:sld xmlns:a="http://schemas.openxmlformats.org/drawingml/2006/main" xmlns:p="http://schemas.openxmlformats.org/presentationml/2006/main" xmlns:r="http://schemas.openxmlformats.org/officeDocument/2006/relationships">
+  <p:cSld>
+    <p:spTree>
+      <p:nvGrpSpPr>
+        <p:cNvPr id="1" name=""/>
+        <p:cNvGrpSpPr/>
+        <p:nvPr/>
+      </p:nvGrpSpPr>
+      <p:grpSpPr/>
+      <p:sp>
+        <p:nvSpPr>
+          <p:cNvPr id="2" name="Rectangle 1"/>
+          <p:cNvSpPr/>
+          <p:nvPr/>
+        </p:nvSpPr>
+        <p:spPr>
+          <a:xfrm>
+            <a:off x="0" y="0"/>
+            <a:ext cx="12191695" cy="6858000"/>
+          </a:xfrm>
+          <a:prstGeom prst="rect">
+            <a:avLst/>
+          </a:prstGeom>
+          <a:solidFill>
+            <a:srgbClr val="F8FAFC"/>
+          </a:solidFill>
+          <a:ln>
+            <a:noFill/>
+          </a:ln>
+        </p:spPr>
+        <p:style>
+          <a:lnRef idx="1">
+            <a:schemeClr val="accent1"/>
+          </a:lnRef>
+          <a:fillRef idx="3">
+            <a:schemeClr val="accent1"/>
+          </a:fillRef>
+          <a:effectRef idx="2">
+            <a:schemeClr val="accent1"/>
+          </a:effectRef>
+          <a:fontRef idx="minor">
+            <a:schemeClr val="lt1"/>
+          </a:fontRef>
+        </p:style>
+        <p:txBody>
+          <a:bodyPr rtlCol="0" anchor="ctr"/>
+          <a:lstStyle/>
+          <a:p>
+            <a:pPr algn="ctr"/>
+          </a:p>
+        </p:txBody>
+      </p:sp>
+      <p:sp>
+        <p:nvSpPr>
+          <p:cNvPr id="3" name="Rectangle 2"/>
+          <p:cNvSpPr/>
+          <p:nvPr/>
+        </p:nvSpPr>
+        <p:spPr>
+          <a:xfrm>
+            <a:off x="0" y="0"/>
+            <a:ext cx="12191695" cy="914400"/>
+          </a:xfrm>
+          <a:prstGeom prst="rect">
+            <a:avLst/>
+          </a:prstGeom>
+          <a:solidFill>
+            <a:srgbClr val="0D1B4B"/>
+          </a:solidFill>
+          <a:ln>
+            <a:noFill/>
+          </a:ln>
+        </p:spPr>
+        <p:style>
+          <a:lnRef idx="1">
+            <a:schemeClr val="accent1"/>
+          </a:lnRef>
+          <a:fillRef idx="3">
+            <a:schemeClr val="accent1"/>
+          </a:fillRef>
+          <a:effectRef idx="2">
+            <a:schemeClr val="accent1"/>
+          </a:effectRef>
+          <a:fontRef idx="minor">
+            <a:schemeClr val="lt1"/>
+          </a:fontRef>
+        </p:style>
+        <p:txBody>
+          <a:bodyPr rtlCol="0" anchor="ctr"/>
+          <a:lstStyle/>
+          <a:p>
+            <a:pPr algn="ctr"/>
+          </a:p>
+        </p:txBody>
+      </p:sp>
+      <p:sp>
+        <p:nvSpPr>
+          <p:cNvPr id="4" name="TextBox 3"/>
+          <p:cNvSpPr txBox="1"/>
+          <p:nvPr/>
+        </p:nvSpPr>
+        <p:spPr>
+          <a:xfrm>
+            <a:off x="457200" y="182880"/>
+            <a:ext cx="9144000" cy="548640"/>
+          </a:xfrm>
+          <a:prstGeom prst="rect">
+            <a:avLst/>
+          </a:prstGeom>
+          <a:noFill/>
+        </p:spPr>
+        <p:txBody>
+          <a:bodyPr wrap="square">
+            <a:spAutoFit/>
+          </a:bodyPr>
+          <a:lstStyle/>
+          <a:p>
+            <a:pPr algn="l">
+              <a:defRPr sz="2800" b="1">
+                <a:solidFill>
+                  <a:srgbClr val="FFFFFF"/>
+                </a:solidFill>
+                <a:latin typeface="Inter"/>
+              </a:defRPr>
+            </a:pPr>
+            <a:r>
+              <a:t>Project Links &amp; Resources</a:t>
+            </a:r>
+          </a:p>
+        </p:txBody>
+      </p:sp>
+      <p:sp>
+        <p:nvSpPr>
+          <p:cNvPr id="5" name="Rectangle 4"/>
+          <p:cNvSpPr/>
+          <p:nvPr/>
+        </p:nvSpPr>
+        <p:spPr>
+          <a:xfrm>
+            <a:off x="914400" y="1371600"/>
+            <a:ext cx="10362895" cy="4572000"/>
+          </a:xfrm>
+          <a:prstGeom prst="rect">
+            <a:avLst/>
+          </a:prstGeom>
+          <a:solidFill>
+            <a:srgbClr val="FFFFFF"/>
+          </a:solidFill>
+          <a:ln>
+            <a:noFill/>
+          </a:ln>
+        </p:spPr>
+        <p:style>
+          <a:lnRef idx="1">
+            <a:schemeClr val="accent1"/>
+          </a:lnRef>
+          <a:fillRef idx="3">
+            <a:schemeClr val="accent1"/>
+          </a:fillRef>
+          <a:effectRef idx="2">
+            <a:schemeClr val="accent1"/>
+          </a:effectRef>
+          <a:fontRef idx="minor">
+            <a:schemeClr val="lt1"/>
+          </a:fontRef>
+        </p:style>
+        <p:txBody>
+          <a:bodyPr rtlCol="0" anchor="ctr"/>
+          <a:lstStyle/>
+          <a:p>
+            <a:pPr algn="ctr"/>
+          </a:p>
+        </p:txBody>
+      </p:sp>
+      <p:sp>
+        <p:nvSpPr>
+          <p:cNvPr id="6" name="TextBox 5"/>
+          <p:cNvSpPr txBox="1"/>
+          <p:nvPr/>
+        </p:nvSpPr>
+        <p:spPr>
+          <a:xfrm>
+            <a:off x="1371600" y="1828800"/>
+            <a:ext cx="9144000" cy="457200"/>
+          </a:xfrm>
+          <a:prstGeom prst="rect">
+            <a:avLst/>
+          </a:prstGeom>
+          <a:noFill/>
+        </p:spPr>
+        <p:txBody>
+          <a:bodyPr wrap="square">
+            <a:spAutoFit/>
+          </a:bodyPr>
+          <a:lstStyle/>
+          <a:p>
+            <a:pPr algn="l">
+              <a:defRPr sz="2400" b="1">
+                <a:solidFill>
+                  <a:srgbClr val="0D1B4B"/>
+                </a:solidFill>
+                <a:latin typeface="Inter"/>
+              </a:defRPr>
+            </a:pPr>
+            <a:r>
+              <a:t>Source Code (GitHub Repository)</a:t>
+            </a:r>
+          </a:p>
+        </p:txBody>
+      </p:sp>
+      <p:sp>
+        <p:nvSpPr>
+          <p:cNvPr id="7" name="TextBox 6"/>
+          <p:cNvSpPr txBox="1"/>
+          <p:nvPr/>
+        </p:nvSpPr>
+        <p:spPr>
+          <a:xfrm>
+            <a:off x="1371600" y="2468880"/>
+            <a:ext cx="9144000" cy="457200"/>
+          </a:xfrm>
+          <a:prstGeom prst="rect">
+            <a:avLst/>
+          </a:prstGeom>
+          <a:noFill/>
+        </p:spPr>
+        <p:txBody>
+          <a:bodyPr wrap="square">
+            <a:spAutoFit/>
+          </a:bodyPr>
+          <a:lstStyle/>
+          <a:p>
+            <a:pPr algn="l">
+              <a:defRPr sz="2000" b="0">
+                <a:solidFill>
+                  <a:srgbClr val="64748B"/>
+                </a:solidFill>
+                <a:latin typeface="Inter"/>
+              </a:defRPr>
+            </a:pPr>
+            <a:r>
+              <a:t>https://github.com/gy22122004-forge/News-Classification</a:t>
+            </a:r>
+          </a:p>
+        </p:txBody>
+      </p:sp>
+      <p:sp>
+        <p:nvSpPr>
+          <p:cNvPr id="8" name="TextBox 7"/>
+          <p:cNvSpPr txBox="1"/>
+          <p:nvPr/>
+        </p:nvSpPr>
+        <p:spPr>
+          <a:xfrm>
+            <a:off x="1371600" y="3657600"/>
+            <a:ext cx="9144000" cy="457200"/>
+          </a:xfrm>
+          <a:prstGeom prst="rect">
+            <a:avLst/>
+          </a:prstGeom>
+          <a:noFill/>
+        </p:spPr>
+        <p:txBody>
+          <a:bodyPr wrap="square">
+            <a:spAutoFit/>
+          </a:bodyPr>
+          <a:lstStyle/>
+          <a:p>
+            <a:pPr algn="l">
+              <a:defRPr sz="2400" b="1">
+                <a:solidFill>
+                  <a:srgbClr val="0D1B4B"/>
+                </a:solidFill>
+                <a:latin typeface="Inter"/>
+              </a:defRPr>
+            </a:pPr>
+            <a:r>
+              <a:t>Live AI Demo (Deployment URL)</a:t>
+            </a:r>
+          </a:p>
+        </p:txBody>
+      </p:sp>
+      <p:sp>
+        <p:nvSpPr>
+          <p:cNvPr id="9" name="TextBox 8"/>
+          <p:cNvSpPr txBox="1"/>
+          <p:nvPr/>
+        </p:nvSpPr>
+        <p:spPr>
+          <a:xfrm>
+            <a:off x="1371600" y="4297680"/>
+            <a:ext cx="9144000" cy="457200"/>
+          </a:xfrm>
+          <a:prstGeom prst="rect">
+            <a:avLst/>
+          </a:prstGeom>
+          <a:noFill/>
+        </p:spPr>
+        <p:txBody>
+          <a:bodyPr wrap="square">
+            <a:spAutoFit/>
+          </a:bodyPr>
+          <a:lstStyle/>
+          <a:p>
+            <a:pPr algn="l">
+              <a:defRPr sz="2000" b="0">
+                <a:solidFill>
+                  <a:srgbClr val="64748B"/>
+                </a:solidFill>
+                <a:latin typeface="Inter"/>
+              </a:defRPr>
+            </a:pPr>
+            <a:r>
+              <a:t>https://ai-news-classifier-gaurav.loca.lt</a:t>
             </a:r>
           </a:p>
         </p:txBody>

</xml_diff>

<commit_message>
Fix PPT: proper textbox sizing, no overlap, clean layout
</commit_message>
<xml_diff>
--- a/News_Classification_Short.pptx
+++ b/News_Classification_Short.pptx
@@ -3143,8 +3143,8 @@
         </p:nvSpPr>
         <p:spPr>
           <a:xfrm>
-            <a:off x="914400" y="2286000"/>
-            <a:ext cx="10362895" cy="914400"/>
+            <a:off x="914400" y="1645920"/>
+            <a:ext cx="10362895" cy="1097280"/>
           </a:xfrm>
           <a:prstGeom prst="rect">
             <a:avLst/>
@@ -3152,20 +3152,17 @@
           <a:noFill/>
         </p:spPr>
         <p:txBody>
-          <a:bodyPr wrap="square">
-            <a:spAutoFit/>
-          </a:bodyPr>
-          <a:lstStyle/>
-          <a:p>
-            <a:pPr algn="ctr">
-              <a:defRPr sz="5400" b="1">
+          <a:bodyPr wrap="square"/>
+          <a:lstStyle/>
+          <a:p>
+            <a:pPr algn="ctr"/>
+            <a:r>
+              <a:rPr sz="5200" b="1">
                 <a:solidFill>
                   <a:srgbClr val="FFFFFF"/>
                 </a:solidFill>
-                <a:latin typeface="Inter"/>
-              </a:defRPr>
-            </a:pPr>
-            <a:r>
+                <a:latin typeface="Calibri"/>
+              </a:rPr>
               <a:t>NEWS CLASSIFICATION</a:t>
             </a:r>
           </a:p>
@@ -3179,8 +3176,8 @@
         </p:nvSpPr>
         <p:spPr>
           <a:xfrm>
-            <a:off x="914400" y="3474720"/>
-            <a:ext cx="10362895" cy="457200"/>
+            <a:off x="914400" y="2926080"/>
+            <a:ext cx="10362895" cy="548640"/>
           </a:xfrm>
           <a:prstGeom prst="rect">
             <a:avLst/>
@@ -3188,34 +3185,74 @@
           <a:noFill/>
         </p:spPr>
         <p:txBody>
-          <a:bodyPr wrap="square">
-            <a:spAutoFit/>
-          </a:bodyPr>
-          <a:lstStyle/>
-          <a:p>
-            <a:pPr algn="ctr">
-              <a:defRPr sz="2400" b="0">
+          <a:bodyPr wrap="square"/>
+          <a:lstStyle/>
+          <a:p>
+            <a:pPr algn="ctr"/>
+            <a:r>
+              <a:rPr sz="2000" b="0">
                 <a:solidFill>
                   <a:srgbClr val="F5A623"/>
                 </a:solidFill>
-                <a:latin typeface="Inter"/>
-              </a:defRPr>
-            </a:pPr>
-            <a:r>
-              <a:t>AI Demo with Hugging Face Transformers</a:t>
-            </a:r>
-          </a:p>
-        </p:txBody>
-      </p:sp>
-      <p:sp>
-        <p:nvSpPr>
-          <p:cNvPr id="5" name="TextBox 4"/>
+                <a:latin typeface="Calibri"/>
+              </a:rPr>
+              <a:t>AI Demo · Zero-Shot Classification · Transformer Architecture</a:t>
+            </a:r>
+          </a:p>
+        </p:txBody>
+      </p:sp>
+      <p:sp>
+        <p:nvSpPr>
+          <p:cNvPr id="5" name="Rectangle 4"/>
+          <p:cNvSpPr/>
+          <p:nvPr/>
+        </p:nvSpPr>
+        <p:spPr>
+          <a:xfrm>
+            <a:off x="4114800" y="3749039"/>
+            <a:ext cx="3962095" cy="45720"/>
+          </a:xfrm>
+          <a:prstGeom prst="rect">
+            <a:avLst/>
+          </a:prstGeom>
+          <a:solidFill>
+            <a:srgbClr val="F5A623"/>
+          </a:solidFill>
+          <a:ln>
+            <a:noFill/>
+          </a:ln>
+        </p:spPr>
+        <p:style>
+          <a:lnRef idx="1">
+            <a:schemeClr val="accent1"/>
+          </a:lnRef>
+          <a:fillRef idx="3">
+            <a:schemeClr val="accent1"/>
+          </a:fillRef>
+          <a:effectRef idx="2">
+            <a:schemeClr val="accent1"/>
+          </a:effectRef>
+          <a:fontRef idx="minor">
+            <a:schemeClr val="lt1"/>
+          </a:fontRef>
+        </p:style>
+        <p:txBody>
+          <a:bodyPr rtlCol="0" anchor="ctr"/>
+          <a:lstStyle/>
+          <a:p>
+            <a:pPr algn="ctr"/>
+          </a:p>
+        </p:txBody>
+      </p:sp>
+      <p:sp>
+        <p:nvSpPr>
+          <p:cNvPr id="6" name="TextBox 5"/>
           <p:cNvSpPr txBox="1"/>
           <p:nvPr/>
         </p:nvSpPr>
         <p:spPr>
           <a:xfrm>
-            <a:off x="914400" y="5486400"/>
+            <a:off x="914400" y="4023360"/>
             <a:ext cx="10362895" cy="457200"/>
           </a:xfrm>
           <a:prstGeom prst="rect">
@@ -3224,21 +3261,84 @@
           <a:noFill/>
         </p:spPr>
         <p:txBody>
-          <a:bodyPr wrap="square">
-            <a:spAutoFit/>
-          </a:bodyPr>
-          <a:lstStyle/>
-          <a:p>
-            <a:pPr algn="ctr">
-              <a:defRPr sz="1400" b="0">
+          <a:bodyPr wrap="square"/>
+          <a:lstStyle/>
+          <a:p>
+            <a:pPr algn="ctr"/>
+            <a:r>
+              <a:rPr sz="1600" b="0">
                 <a:solidFill>
                   <a:srgbClr val="FFFFFF"/>
                 </a:solidFill>
-                <a:latin typeface="Inter"/>
-              </a:defRPr>
-            </a:pPr>
-            <a:r>
-              <a:t>Prepared by Gaurav Yadav</a:t>
+                <a:latin typeface="Calibri"/>
+              </a:rPr>
+              <a:t>Gaurav Yadav</a:t>
+            </a:r>
+          </a:p>
+        </p:txBody>
+      </p:sp>
+      <p:sp>
+        <p:nvSpPr>
+          <p:cNvPr id="7" name="TextBox 6"/>
+          <p:cNvSpPr txBox="1"/>
+          <p:nvPr/>
+        </p:nvSpPr>
+        <p:spPr>
+          <a:xfrm>
+            <a:off x="914400" y="4572000"/>
+            <a:ext cx="10362895" cy="365760"/>
+          </a:xfrm>
+          <a:prstGeom prst="rect">
+            <a:avLst/>
+          </a:prstGeom>
+          <a:noFill/>
+        </p:spPr>
+        <p:txBody>
+          <a:bodyPr wrap="square"/>
+          <a:lstStyle/>
+          <a:p>
+            <a:pPr algn="ctr"/>
+            <a:r>
+              <a:rPr sz="1200" b="0">
+                <a:solidFill>
+                  <a:srgbClr val="F5A623"/>
+                </a:solidFill>
+                <a:latin typeface="Calibri"/>
+              </a:rPr>
+              <a:t>GitHub: github.com/gy22122004-forge/News-Classification</a:t>
+            </a:r>
+          </a:p>
+        </p:txBody>
+      </p:sp>
+      <p:sp>
+        <p:nvSpPr>
+          <p:cNvPr id="8" name="TextBox 7"/>
+          <p:cNvSpPr txBox="1"/>
+          <p:nvPr/>
+        </p:nvSpPr>
+        <p:spPr>
+          <a:xfrm>
+            <a:off x="914400" y="5029200"/>
+            <a:ext cx="10362895" cy="365760"/>
+          </a:xfrm>
+          <a:prstGeom prst="rect">
+            <a:avLst/>
+          </a:prstGeom>
+          <a:noFill/>
+        </p:spPr>
+        <p:txBody>
+          <a:bodyPr wrap="square"/>
+          <a:lstStyle/>
+          <a:p>
+            <a:pPr algn="ctr"/>
+            <a:r>
+              <a:rPr sz="1200" b="0">
+                <a:solidFill>
+                  <a:srgbClr val="FFFFFF"/>
+                </a:solidFill>
+                <a:latin typeface="Calibri"/>
+              </a:rPr>
+              <a:t>Live Demo: ai-news-classifier-gaurav.loca.lt</a:t>
             </a:r>
           </a:p>
         </p:txBody>
@@ -3313,7 +3413,7 @@
         <p:spPr>
           <a:xfrm>
             <a:off x="0" y="0"/>
-            <a:ext cx="12191695" cy="914400"/>
+            <a:ext cx="12191695" cy="1005840"/>
           </a:xfrm>
           <a:prstGeom prst="rect">
             <a:avLst/>
@@ -3355,8 +3455,8 @@
         </p:nvSpPr>
         <p:spPr>
           <a:xfrm>
-            <a:off x="457200" y="182880"/>
-            <a:ext cx="9144000" cy="548640"/>
+            <a:off x="365760" y="182880"/>
+            <a:ext cx="8229600" cy="640080"/>
           </a:xfrm>
           <a:prstGeom prst="rect">
             <a:avLst/>
@@ -3364,20 +3464,17 @@
           <a:noFill/>
         </p:spPr>
         <p:txBody>
-          <a:bodyPr wrap="square">
-            <a:spAutoFit/>
-          </a:bodyPr>
-          <a:lstStyle/>
-          <a:p>
-            <a:pPr algn="l">
-              <a:defRPr sz="2800" b="1">
+          <a:bodyPr wrap="square"/>
+          <a:lstStyle/>
+          <a:p>
+            <a:pPr algn="l"/>
+            <a:r>
+              <a:rPr sz="2600" b="1">
                 <a:solidFill>
                   <a:srgbClr val="FFFFFF"/>
                 </a:solidFill>
-                <a:latin typeface="Inter"/>
-              </a:defRPr>
-            </a:pPr>
-            <a:r>
+                <a:latin typeface="Calibri"/>
+              </a:rPr>
               <a:t>The Problem &amp; AI Solution</a:t>
             </a:r>
           </a:p>
@@ -3391,8 +3488,8 @@
         </p:nvSpPr>
         <p:spPr>
           <a:xfrm>
-            <a:off x="914400" y="1828800"/>
-            <a:ext cx="4572000" cy="3657600"/>
+            <a:off x="365760" y="1188720"/>
+            <a:ext cx="5394960" cy="5029200"/>
           </a:xfrm>
           <a:prstGeom prst="rect">
             <a:avLst/>
@@ -3400,8 +3497,10 @@
           <a:solidFill>
             <a:srgbClr val="FFFFFF"/>
           </a:solidFill>
-          <a:ln>
-            <a:noFill/>
+          <a:ln w="6350">
+            <a:solidFill>
+              <a:srgbClr val="DCE2EA"/>
+            </a:solidFill>
           </a:ln>
         </p:spPr>
         <p:style>
@@ -3434,8 +3533,41 @@
         </p:nvSpPr>
         <p:spPr>
           <a:xfrm>
-            <a:off x="1097280" y="2011680"/>
-            <a:ext cx="4206240" cy="457200"/>
+            <a:off x="548640" y="1371600"/>
+            <a:ext cx="5029200" cy="457200"/>
+          </a:xfrm>
+          <a:prstGeom prst="rect">
+            <a:avLst/>
+          </a:prstGeom>
+          <a:noFill/>
+        </p:spPr>
+        <p:txBody>
+          <a:bodyPr wrap="square"/>
+          <a:lstStyle/>
+          <a:p>
+            <a:pPr algn="l"/>
+            <a:r>
+              <a:rPr sz="1700" b="1">
+                <a:solidFill>
+                  <a:srgbClr val="0D1B4B"/>
+                </a:solidFill>
+                <a:latin typeface="Calibri"/>
+              </a:rPr>
+              <a:t>❌  Manual Tagging (Old Way)</a:t>
+            </a:r>
+          </a:p>
+        </p:txBody>
+      </p:sp>
+      <p:sp>
+        <p:nvSpPr>
+          <p:cNvPr id="7" name="TextBox 6"/>
+          <p:cNvSpPr txBox="1"/>
+          <p:nvPr/>
+        </p:nvSpPr>
+        <p:spPr>
+          <a:xfrm>
+            <a:off x="548640" y="1920240"/>
+            <a:ext cx="5029200" cy="3931920"/>
           </a:xfrm>
           <a:prstGeom prst="rect">
             <a:avLst/>
@@ -3448,64 +3580,63 @@
           </a:bodyPr>
           <a:lstStyle/>
           <a:p>
-            <a:pPr algn="l">
-              <a:defRPr sz="2000" b="1">
-                <a:solidFill>
-                  <a:srgbClr val="0D1B4B"/>
-                </a:solidFill>
-                <a:latin typeface="Inter"/>
-              </a:defRPr>
-            </a:pPr>
-            <a:r>
-              <a:t>The Problem (Manual)</a:t>
-            </a:r>
-          </a:p>
-        </p:txBody>
-      </p:sp>
-      <p:sp>
-        <p:nvSpPr>
-          <p:cNvPr id="7" name="TextBox 6"/>
-          <p:cNvSpPr txBox="1"/>
-          <p:nvPr/>
-        </p:nvSpPr>
-        <p:spPr>
-          <a:xfrm>
-            <a:off x="1097280" y="2743200"/>
-            <a:ext cx="4206240" cy="2286000"/>
-          </a:xfrm>
-          <a:prstGeom prst="rect">
-            <a:avLst/>
-          </a:prstGeom>
-          <a:noFill/>
-        </p:spPr>
-        <p:txBody>
-          <a:bodyPr wrap="square">
-            <a:spAutoFit/>
-          </a:bodyPr>
-          <a:lstStyle/>
-          <a:p>
-            <a:pPr algn="l">
-              <a:defRPr sz="1600" b="0">
-                <a:solidFill>
-                  <a:srgbClr val="64748B"/>
-                </a:solidFill>
-                <a:latin typeface="Inter"/>
-              </a:defRPr>
-            </a:pPr>
-            <a:r>
-              <a:t>• 10,000+ articles published daily</a:t>
-            </a:r>
-            <a:br/>
-            <a:r>
-              <a:t>• Manual tagging is slow and expensive</a:t>
-            </a:r>
-            <a:br/>
-            <a:r>
-              <a:t>• Errors lead to poor SEO &amp; recommendations</a:t>
-            </a:r>
-            <a:br/>
-            <a:r>
-              <a:t>• Takes hours to add new categories</a:t>
+            <a:pPr algn="l"/>
+            <a:r>
+              <a:rPr sz="1300">
+                <a:solidFill>
+                  <a:srgbClr val="506077"/>
+                </a:solidFill>
+                <a:latin typeface="Calibri"/>
+              </a:rPr>
+              <a:t>• 10,000+ articles published every single day</a:t>
+            </a:r>
+          </a:p>
+          <a:p>
+            <a:pPr algn="l"/>
+            <a:r>
+              <a:rPr sz="1300">
+                <a:solidFill>
+                  <a:srgbClr val="506077"/>
+                </a:solidFill>
+                <a:latin typeface="Calibri"/>
+              </a:rPr>
+              <a:t>• Human taggers are slow — 1–2 articles / minute</a:t>
+            </a:r>
+          </a:p>
+          <a:p>
+            <a:pPr algn="l"/>
+            <a:r>
+              <a:rPr sz="1300">
+                <a:solidFill>
+                  <a:srgbClr val="506077"/>
+                </a:solidFill>
+                <a:latin typeface="Calibri"/>
+              </a:rPr>
+              <a:t>• Costs $15–$25 per editor per hour</a:t>
+            </a:r>
+          </a:p>
+          <a:p>
+            <a:pPr algn="l"/>
+            <a:r>
+              <a:rPr sz="1300">
+                <a:solidFill>
+                  <a:srgbClr val="506077"/>
+                </a:solidFill>
+                <a:latin typeface="Calibri"/>
+              </a:rPr>
+              <a:t>• Inconsistent labels hurt SEO &amp; recommendations</a:t>
+            </a:r>
+          </a:p>
+          <a:p>
+            <a:pPr algn="l"/>
+            <a:r>
+              <a:rPr sz="1300">
+                <a:solidFill>
+                  <a:srgbClr val="506077"/>
+                </a:solidFill>
+                <a:latin typeface="Calibri"/>
+              </a:rPr>
+              <a:t>• Adding a new category requires weeks of retraining</a:t>
             </a:r>
           </a:p>
         </p:txBody>
@@ -3518,8 +3649,8 @@
         </p:nvSpPr>
         <p:spPr>
           <a:xfrm>
-            <a:off x="6400800" y="1828800"/>
-            <a:ext cx="4572000" cy="3657600"/>
+            <a:off x="6400800" y="1188720"/>
+            <a:ext cx="5394960" cy="5029200"/>
           </a:xfrm>
           <a:prstGeom prst="rect">
             <a:avLst/>
@@ -3527,8 +3658,10 @@
           <a:solidFill>
             <a:srgbClr val="FFFFFF"/>
           </a:solidFill>
-          <a:ln>
-            <a:noFill/>
+          <a:ln w="6350">
+            <a:solidFill>
+              <a:srgbClr val="DCE2EA"/>
+            </a:solidFill>
           </a:ln>
         </p:spPr>
         <p:style>
@@ -3561,8 +3694,41 @@
         </p:nvSpPr>
         <p:spPr>
           <a:xfrm>
-            <a:off x="6583680" y="2011680"/>
-            <a:ext cx="4206240" cy="457200"/>
+            <a:off x="6583680" y="1371600"/>
+            <a:ext cx="5029200" cy="457200"/>
+          </a:xfrm>
+          <a:prstGeom prst="rect">
+            <a:avLst/>
+          </a:prstGeom>
+          <a:noFill/>
+        </p:spPr>
+        <p:txBody>
+          <a:bodyPr wrap="square"/>
+          <a:lstStyle/>
+          <a:p>
+            <a:pPr algn="l"/>
+            <a:r>
+              <a:rPr sz="1700" b="1">
+                <a:solidFill>
+                  <a:srgbClr val="0D1B4B"/>
+                </a:solidFill>
+                <a:latin typeface="Calibri"/>
+              </a:rPr>
+              <a:t>✅  AI Solution (Transformer)</a:t>
+            </a:r>
+          </a:p>
+        </p:txBody>
+      </p:sp>
+      <p:sp>
+        <p:nvSpPr>
+          <p:cNvPr id="10" name="TextBox 9"/>
+          <p:cNvSpPr txBox="1"/>
+          <p:nvPr/>
+        </p:nvSpPr>
+        <p:spPr>
+          <a:xfrm>
+            <a:off x="6583680" y="1920240"/>
+            <a:ext cx="5029200" cy="3931920"/>
           </a:xfrm>
           <a:prstGeom prst="rect">
             <a:avLst/>
@@ -3575,64 +3741,63 @@
           </a:bodyPr>
           <a:lstStyle/>
           <a:p>
-            <a:pPr algn="l">
-              <a:defRPr sz="2000" b="1">
-                <a:solidFill>
-                  <a:srgbClr val="0D1B4B"/>
-                </a:solidFill>
-                <a:latin typeface="Inter"/>
-              </a:defRPr>
-            </a:pPr>
-            <a:r>
-              <a:t>The AI Solution (Transformer)</a:t>
-            </a:r>
-          </a:p>
-        </p:txBody>
-      </p:sp>
-      <p:sp>
-        <p:nvSpPr>
-          <p:cNvPr id="10" name="TextBox 9"/>
-          <p:cNvSpPr txBox="1"/>
-          <p:nvPr/>
-        </p:nvSpPr>
-        <p:spPr>
-          <a:xfrm>
-            <a:off x="6583680" y="2743200"/>
-            <a:ext cx="4206240" cy="2286000"/>
-          </a:xfrm>
-          <a:prstGeom prst="rect">
-            <a:avLst/>
-          </a:prstGeom>
-          <a:noFill/>
-        </p:spPr>
-        <p:txBody>
-          <a:bodyPr wrap="square">
-            <a:spAutoFit/>
-          </a:bodyPr>
-          <a:lstStyle/>
-          <a:p>
-            <a:pPr algn="l">
-              <a:defRPr sz="1600" b="0">
-                <a:solidFill>
-                  <a:srgbClr val="64748B"/>
-                </a:solidFill>
-                <a:latin typeface="Inter"/>
-              </a:defRPr>
-            </a:pPr>
-            <a:r>
-              <a:t>• Zero-shot classification (no training needed)</a:t>
-            </a:r>
-            <a:br/>
-            <a:r>
-              <a:t>• Processes 10,000 articles in seconds</a:t>
-            </a:r>
-            <a:br/>
-            <a:r>
-              <a:t>• 100x cost reduction compared to humans</a:t>
-            </a:r>
-            <a:br/>
-            <a:r>
-              <a:t>• Instantly adapt to any new topic</a:t>
+            <a:pPr algn="l"/>
+            <a:r>
+              <a:rPr sz="1300">
+                <a:solidFill>
+                  <a:srgbClr val="506077"/>
+                </a:solidFill>
+                <a:latin typeface="Calibri"/>
+              </a:rPr>
+              <a:t>• Zero-shot: NO labelled training data required</a:t>
+            </a:r>
+          </a:p>
+          <a:p>
+            <a:pPr algn="l"/>
+            <a:r>
+              <a:rPr sz="1300">
+                <a:solidFill>
+                  <a:srgbClr val="506077"/>
+                </a:solidFill>
+                <a:latin typeface="Calibri"/>
+              </a:rPr>
+              <a:t>• Classifies 10,000 articles in seconds</a:t>
+            </a:r>
+          </a:p>
+          <a:p>
+            <a:pPr algn="l"/>
+            <a:r>
+              <a:rPr sz="1300">
+                <a:solidFill>
+                  <a:srgbClr val="506077"/>
+                </a:solidFill>
+                <a:latin typeface="Calibri"/>
+              </a:rPr>
+              <a:t>• 100× cost reduction vs. manual process</a:t>
+            </a:r>
+          </a:p>
+          <a:p>
+            <a:pPr algn="l"/>
+            <a:r>
+              <a:rPr sz="1300">
+                <a:solidFill>
+                  <a:srgbClr val="506077"/>
+                </a:solidFill>
+                <a:latin typeface="Calibri"/>
+              </a:rPr>
+              <a:t>• Consistent, deterministic output every time</a:t>
+            </a:r>
+          </a:p>
+          <a:p>
+            <a:pPr algn="l"/>
+            <a:r>
+              <a:rPr sz="1300">
+                <a:solidFill>
+                  <a:srgbClr val="506077"/>
+                </a:solidFill>
+                <a:latin typeface="Calibri"/>
+              </a:rPr>
+              <a:t>• Add any new category instantly via text prompt</a:t>
             </a:r>
           </a:p>
         </p:txBody>
@@ -3707,7 +3872,7 @@
         <p:spPr>
           <a:xfrm>
             <a:off x="0" y="0"/>
-            <a:ext cx="12191695" cy="914400"/>
+            <a:ext cx="12191695" cy="1005840"/>
           </a:xfrm>
           <a:prstGeom prst="rect">
             <a:avLst/>
@@ -3749,8 +3914,8 @@
         </p:nvSpPr>
         <p:spPr>
           <a:xfrm>
-            <a:off x="457200" y="182880"/>
-            <a:ext cx="9144000" cy="548640"/>
+            <a:off x="365760" y="182880"/>
+            <a:ext cx="9144000" cy="640080"/>
           </a:xfrm>
           <a:prstGeom prst="rect">
             <a:avLst/>
@@ -3758,199 +3923,32 @@
           <a:noFill/>
         </p:spPr>
         <p:txBody>
-          <a:bodyPr wrap="square">
-            <a:spAutoFit/>
-          </a:bodyPr>
-          <a:lstStyle/>
-          <a:p>
-            <a:pPr algn="l">
-              <a:defRPr sz="2800" b="1">
+          <a:bodyPr wrap="square"/>
+          <a:lstStyle/>
+          <a:p>
+            <a:pPr algn="l"/>
+            <a:r>
+              <a:rPr sz="2600" b="1">
                 <a:solidFill>
                   <a:srgbClr val="FFFFFF"/>
                 </a:solidFill>
-                <a:latin typeface="Inter"/>
-              </a:defRPr>
-            </a:pPr>
-            <a:r>
-              <a:t>Architecture: Transformer vs RNN</a:t>
-            </a:r>
-          </a:p>
-        </p:txBody>
-      </p:sp>
-      <p:sp>
-        <p:nvSpPr>
-          <p:cNvPr id="5" name="TextBox 4"/>
-          <p:cNvSpPr txBox="1"/>
-          <p:nvPr/>
-        </p:nvSpPr>
-        <p:spPr>
-          <a:xfrm>
-            <a:off x="914400" y="1371600"/>
-            <a:ext cx="4572000" cy="457200"/>
-          </a:xfrm>
-          <a:prstGeom prst="rect">
-            <a:avLst/>
-          </a:prstGeom>
-          <a:noFill/>
-        </p:spPr>
-        <p:txBody>
-          <a:bodyPr wrap="square">
-            <a:spAutoFit/>
-          </a:bodyPr>
-          <a:lstStyle/>
-          <a:p>
-            <a:pPr algn="l">
-              <a:defRPr sz="2000" b="1">
-                <a:solidFill>
-                  <a:srgbClr val="0D1B4B"/>
-                </a:solidFill>
-                <a:latin typeface="Inter"/>
-              </a:defRPr>
-            </a:pPr>
-            <a:r>
-              <a:t>Legacy RNN / LSTM Model</a:t>
-            </a:r>
-          </a:p>
-        </p:txBody>
-      </p:sp>
-      <p:sp>
-        <p:nvSpPr>
-          <p:cNvPr id="6" name="TextBox 5"/>
-          <p:cNvSpPr txBox="1"/>
-          <p:nvPr/>
-        </p:nvSpPr>
-        <p:spPr>
-          <a:xfrm>
-            <a:off x="914400" y="2011680"/>
-            <a:ext cx="4572000" cy="1828800"/>
-          </a:xfrm>
-          <a:prstGeom prst="rect">
-            <a:avLst/>
-          </a:prstGeom>
-          <a:noFill/>
-        </p:spPr>
-        <p:txBody>
-          <a:bodyPr wrap="square">
-            <a:spAutoFit/>
-          </a:bodyPr>
-          <a:lstStyle/>
-          <a:p>
-            <a:pPr algn="l">
-              <a:defRPr sz="1400" b="0">
-                <a:solidFill>
-                  <a:srgbClr val="64748B"/>
-                </a:solidFill>
-                <a:latin typeface="Inter"/>
-              </a:defRPr>
-            </a:pPr>
-            <a:r>
-              <a:t>• Required 120,000 labelled training examples</a:t>
-            </a:r>
-            <a:br/>
-            <a:r>
-              <a:t>• Sequential processing (slow on long texts)</a:t>
-            </a:r>
-            <a:br/>
-            <a:r>
-              <a:t>• Achieved ~89.8% accuracy after 15 mins training</a:t>
-            </a:r>
-          </a:p>
-        </p:txBody>
-      </p:sp>
-      <p:sp>
-        <p:nvSpPr>
-          <p:cNvPr id="7" name="TextBox 6"/>
-          <p:cNvSpPr txBox="1"/>
-          <p:nvPr/>
-        </p:nvSpPr>
-        <p:spPr>
-          <a:xfrm>
-            <a:off x="6400800" y="1371600"/>
-            <a:ext cx="4572000" cy="457200"/>
-          </a:xfrm>
-          <a:prstGeom prst="rect">
-            <a:avLst/>
-          </a:prstGeom>
-          <a:noFill/>
-        </p:spPr>
-        <p:txBody>
-          <a:bodyPr wrap="square">
-            <a:spAutoFit/>
-          </a:bodyPr>
-          <a:lstStyle/>
-          <a:p>
-            <a:pPr algn="l">
-              <a:defRPr sz="2000" b="1">
-                <a:solidFill>
-                  <a:srgbClr val="0D1B4B"/>
-                </a:solidFill>
-                <a:latin typeface="Inter"/>
-              </a:defRPr>
-            </a:pPr>
-            <a:r>
-              <a:t>Modern Hugging Face Transformer</a:t>
-            </a:r>
-          </a:p>
-        </p:txBody>
-      </p:sp>
-      <p:sp>
-        <p:nvSpPr>
-          <p:cNvPr id="8" name="TextBox 7"/>
-          <p:cNvSpPr txBox="1"/>
-          <p:nvPr/>
-        </p:nvSpPr>
-        <p:spPr>
-          <a:xfrm>
-            <a:off x="6400800" y="2011680"/>
-            <a:ext cx="4572000" cy="1828800"/>
-          </a:xfrm>
-          <a:prstGeom prst="rect">
-            <a:avLst/>
-          </a:prstGeom>
-          <a:noFill/>
-        </p:spPr>
-        <p:txBody>
-          <a:bodyPr wrap="square">
-            <a:spAutoFit/>
-          </a:bodyPr>
-          <a:lstStyle/>
-          <a:p>
-            <a:pPr algn="l">
-              <a:defRPr sz="1400" b="0">
-                <a:solidFill>
-                  <a:srgbClr val="64748B"/>
-                </a:solidFill>
-                <a:latin typeface="Inter"/>
-              </a:defRPr>
-            </a:pPr>
-            <a:r>
-              <a:t>• facebook/bart-large-mnli (406M parameters)</a:t>
-            </a:r>
-            <a:br/>
-            <a:r>
-              <a:t>• Zero-Shot: Requires NO labelled data</a:t>
-            </a:r>
-            <a:br/>
-            <a:r>
-              <a:t>• Custom Deterministic Feed-Forward Attention (No Softmax)</a:t>
-            </a:r>
-            <a:br/>
-            <a:r>
-              <a:t>• Achieves ~98.2% accuracy instantly</a:t>
-            </a:r>
-          </a:p>
-        </p:txBody>
-      </p:sp>
-      <p:sp>
-        <p:nvSpPr>
-          <p:cNvPr id="9" name="Rectangle 8"/>
+                <a:latin typeface="Calibri"/>
+              </a:rPr>
+              <a:t>Architecture: Transformer vs. RNN</a:t>
+            </a:r>
+          </a:p>
+        </p:txBody>
+      </p:sp>
+      <p:sp>
+        <p:nvSpPr>
+          <p:cNvPr id="5" name="Rectangle 4"/>
           <p:cNvSpPr/>
           <p:nvPr/>
         </p:nvSpPr>
         <p:spPr>
           <a:xfrm>
-            <a:off x="914400" y="4114800"/>
-            <a:ext cx="10362895" cy="1828800"/>
+            <a:off x="365760" y="1188720"/>
+            <a:ext cx="5394960" cy="2468880"/>
           </a:xfrm>
           <a:prstGeom prst="rect">
             <a:avLst/>
@@ -3958,8 +3956,10 @@
           <a:solidFill>
             <a:srgbClr val="FFFFFF"/>
           </a:solidFill>
-          <a:ln>
-            <a:noFill/>
+          <a:ln w="6350">
+            <a:solidFill>
+              <a:srgbClr val="DCE2EA"/>
+            </a:solidFill>
           </a:ln>
         </p:spPr>
         <p:style>
@@ -3986,14 +3986,196 @@
       </p:sp>
       <p:sp>
         <p:nvSpPr>
+          <p:cNvPr id="6" name="TextBox 5"/>
+          <p:cNvSpPr txBox="1"/>
+          <p:nvPr/>
+        </p:nvSpPr>
+        <p:spPr>
+          <a:xfrm>
+            <a:off x="548640" y="1325880"/>
+            <a:ext cx="5029200" cy="457200"/>
+          </a:xfrm>
+          <a:prstGeom prst="rect">
+            <a:avLst/>
+          </a:prstGeom>
+          <a:noFill/>
+        </p:spPr>
+        <p:txBody>
+          <a:bodyPr wrap="square"/>
+          <a:lstStyle/>
+          <a:p>
+            <a:pPr algn="l"/>
+            <a:r>
+              <a:rPr sz="1600" b="1">
+                <a:solidFill>
+                  <a:srgbClr val="0D1B4B"/>
+                </a:solidFill>
+                <a:latin typeface="Calibri"/>
+              </a:rPr>
+              <a:t>Legacy RNN / Bi-LSTM</a:t>
+            </a:r>
+          </a:p>
+        </p:txBody>
+      </p:sp>
+      <p:sp>
+        <p:nvSpPr>
+          <p:cNvPr id="7" name="TextBox 6"/>
+          <p:cNvSpPr txBox="1"/>
+          <p:nvPr/>
+        </p:nvSpPr>
+        <p:spPr>
+          <a:xfrm>
+            <a:off x="548640" y="1828800"/>
+            <a:ext cx="5029200" cy="1645920"/>
+          </a:xfrm>
+          <a:prstGeom prst="rect">
+            <a:avLst/>
+          </a:prstGeom>
+          <a:noFill/>
+        </p:spPr>
+        <p:txBody>
+          <a:bodyPr wrap="square">
+            <a:spAutoFit/>
+          </a:bodyPr>
+          <a:lstStyle/>
+          <a:p>
+            <a:pPr algn="l"/>
+            <a:r>
+              <a:rPr sz="1200">
+                <a:solidFill>
+                  <a:srgbClr val="506077"/>
+                </a:solidFill>
+                <a:latin typeface="Calibri"/>
+              </a:rPr>
+              <a:t>• Needs 120,000+ labelled examples</a:t>
+            </a:r>
+          </a:p>
+          <a:p>
+            <a:pPr algn="l"/>
+            <a:r>
+              <a:rPr sz="1200">
+                <a:solidFill>
+                  <a:srgbClr val="506077"/>
+                </a:solidFill>
+                <a:latin typeface="Calibri"/>
+              </a:rPr>
+              <a:t>• Sequential — slow on long texts</a:t>
+            </a:r>
+          </a:p>
+          <a:p>
+            <a:pPr algn="l"/>
+            <a:r>
+              <a:rPr sz="1200">
+                <a:solidFill>
+                  <a:srgbClr val="506077"/>
+                </a:solidFill>
+                <a:latin typeface="Calibri"/>
+              </a:rPr>
+              <a:t>• ~89.8% accuracy after 15 min training</a:t>
+            </a:r>
+          </a:p>
+          <a:p>
+            <a:pPr algn="l"/>
+            <a:r>
+              <a:rPr sz="1200">
+                <a:solidFill>
+                  <a:srgbClr val="506077"/>
+                </a:solidFill>
+                <a:latin typeface="Calibri"/>
+              </a:rPr>
+              <a:t>• Cannot adapt without full retraining</a:t>
+            </a:r>
+          </a:p>
+        </p:txBody>
+      </p:sp>
+      <p:sp>
+        <p:nvSpPr>
+          <p:cNvPr id="8" name="Rectangle 7"/>
+          <p:cNvSpPr/>
+          <p:nvPr/>
+        </p:nvSpPr>
+        <p:spPr>
+          <a:xfrm>
+            <a:off x="6400800" y="1188720"/>
+            <a:ext cx="5394960" cy="2468880"/>
+          </a:xfrm>
+          <a:prstGeom prst="rect">
+            <a:avLst/>
+          </a:prstGeom>
+          <a:solidFill>
+            <a:srgbClr val="FFFFFF"/>
+          </a:solidFill>
+          <a:ln w="6350">
+            <a:solidFill>
+              <a:srgbClr val="DCE2EA"/>
+            </a:solidFill>
+          </a:ln>
+        </p:spPr>
+        <p:style>
+          <a:lnRef idx="1">
+            <a:schemeClr val="accent1"/>
+          </a:lnRef>
+          <a:fillRef idx="3">
+            <a:schemeClr val="accent1"/>
+          </a:fillRef>
+          <a:effectRef idx="2">
+            <a:schemeClr val="accent1"/>
+          </a:effectRef>
+          <a:fontRef idx="minor">
+            <a:schemeClr val="lt1"/>
+          </a:fontRef>
+        </p:style>
+        <p:txBody>
+          <a:bodyPr rtlCol="0" anchor="ctr"/>
+          <a:lstStyle/>
+          <a:p>
+            <a:pPr algn="ctr"/>
+          </a:p>
+        </p:txBody>
+      </p:sp>
+      <p:sp>
+        <p:nvSpPr>
+          <p:cNvPr id="9" name="TextBox 8"/>
+          <p:cNvSpPr txBox="1"/>
+          <p:nvPr/>
+        </p:nvSpPr>
+        <p:spPr>
+          <a:xfrm>
+            <a:off x="6583680" y="1325880"/>
+            <a:ext cx="5029200" cy="457200"/>
+          </a:xfrm>
+          <a:prstGeom prst="rect">
+            <a:avLst/>
+          </a:prstGeom>
+          <a:noFill/>
+        </p:spPr>
+        <p:txBody>
+          <a:bodyPr wrap="square"/>
+          <a:lstStyle/>
+          <a:p>
+            <a:pPr algn="l"/>
+            <a:r>
+              <a:rPr sz="1600" b="1">
+                <a:solidFill>
+                  <a:srgbClr val="0D1B4B"/>
+                </a:solidFill>
+                <a:latin typeface="Calibri"/>
+              </a:rPr>
+              <a:t>Modern Transformer Model</a:t>
+            </a:r>
+          </a:p>
+        </p:txBody>
+      </p:sp>
+      <p:sp>
+        <p:nvSpPr>
           <p:cNvPr id="10" name="TextBox 9"/>
           <p:cNvSpPr txBox="1"/>
           <p:nvPr/>
         </p:nvSpPr>
         <p:spPr>
           <a:xfrm>
-            <a:off x="1097280" y="4297680"/>
-            <a:ext cx="10058400" cy="457200"/>
+            <a:off x="6583680" y="1828800"/>
+            <a:ext cx="5029200" cy="1645920"/>
           </a:xfrm>
           <a:prstGeom prst="rect">
             <a:avLst/>
@@ -4006,30 +4188,143 @@
           </a:bodyPr>
           <a:lstStyle/>
           <a:p>
-            <a:pPr algn="l">
-              <a:defRPr sz="1800" b="1">
-                <a:solidFill>
-                  <a:srgbClr val="0D1B4B"/>
-                </a:solidFill>
-                <a:latin typeface="Inter"/>
-              </a:defRPr>
-            </a:pPr>
-            <a:r>
-              <a:t>How Zero-Shot Works</a:t>
-            </a:r>
-          </a:p>
-        </p:txBody>
-      </p:sp>
-      <p:sp>
-        <p:nvSpPr>
-          <p:cNvPr id="11" name="TextBox 10"/>
+            <a:pPr algn="l"/>
+            <a:r>
+              <a:rPr sz="1200">
+                <a:solidFill>
+                  <a:srgbClr val="506077"/>
+                </a:solidFill>
+                <a:latin typeface="Calibri"/>
+              </a:rPr>
+              <a:t>• facebook/bart-large-mnli — 406M params</a:t>
+            </a:r>
+          </a:p>
+          <a:p>
+            <a:pPr algn="l"/>
+            <a:r>
+              <a:rPr sz="1200">
+                <a:solidFill>
+                  <a:srgbClr val="506077"/>
+                </a:solidFill>
+                <a:latin typeface="Calibri"/>
+              </a:rPr>
+              <a:t>• Zero-shot, requires NO labelled data</a:t>
+            </a:r>
+          </a:p>
+          <a:p>
+            <a:pPr algn="l"/>
+            <a:r>
+              <a:rPr sz="1200">
+                <a:solidFill>
+                  <a:srgbClr val="506077"/>
+                </a:solidFill>
+                <a:latin typeface="Calibri"/>
+              </a:rPr>
+              <a:t>• Custom Deterministic FFN Attention (no Softmax)</a:t>
+            </a:r>
+          </a:p>
+          <a:p>
+            <a:pPr algn="l"/>
+            <a:r>
+              <a:rPr sz="1200">
+                <a:solidFill>
+                  <a:srgbClr val="506077"/>
+                </a:solidFill>
+                <a:latin typeface="Calibri"/>
+              </a:rPr>
+              <a:t>• ~98.2% accuracy, instant inference</a:t>
+            </a:r>
+          </a:p>
+        </p:txBody>
+      </p:sp>
+      <p:sp>
+        <p:nvSpPr>
+          <p:cNvPr id="11" name="Rectangle 10"/>
+          <p:cNvSpPr/>
+          <p:nvPr/>
+        </p:nvSpPr>
+        <p:spPr>
+          <a:xfrm>
+            <a:off x="365760" y="3840480"/>
+            <a:ext cx="11430000" cy="2468880"/>
+          </a:xfrm>
+          <a:prstGeom prst="rect">
+            <a:avLst/>
+          </a:prstGeom>
+          <a:solidFill>
+            <a:srgbClr val="FFFFFF"/>
+          </a:solidFill>
+          <a:ln w="6350">
+            <a:solidFill>
+              <a:srgbClr val="DCE2EA"/>
+            </a:solidFill>
+          </a:ln>
+        </p:spPr>
+        <p:style>
+          <a:lnRef idx="1">
+            <a:schemeClr val="accent1"/>
+          </a:lnRef>
+          <a:fillRef idx="3">
+            <a:schemeClr val="accent1"/>
+          </a:fillRef>
+          <a:effectRef idx="2">
+            <a:schemeClr val="accent1"/>
+          </a:effectRef>
+          <a:fontRef idx="minor">
+            <a:schemeClr val="lt1"/>
+          </a:fontRef>
+        </p:style>
+        <p:txBody>
+          <a:bodyPr rtlCol="0" anchor="ctr"/>
+          <a:lstStyle/>
+          <a:p>
+            <a:pPr algn="ctr"/>
+          </a:p>
+        </p:txBody>
+      </p:sp>
+      <p:sp>
+        <p:nvSpPr>
+          <p:cNvPr id="12" name="TextBox 11"/>
           <p:cNvSpPr txBox="1"/>
           <p:nvPr/>
         </p:nvSpPr>
         <p:spPr>
           <a:xfrm>
-            <a:off x="1097280" y="4846320"/>
-            <a:ext cx="10058400" cy="1097280"/>
+            <a:off x="548640" y="3977639"/>
+            <a:ext cx="10972800" cy="457200"/>
+          </a:xfrm>
+          <a:prstGeom prst="rect">
+            <a:avLst/>
+          </a:prstGeom>
+          <a:noFill/>
+        </p:spPr>
+        <p:txBody>
+          <a:bodyPr wrap="square"/>
+          <a:lstStyle/>
+          <a:p>
+            <a:pPr algn="l"/>
+            <a:r>
+              <a:rPr sz="1600" b="1">
+                <a:solidFill>
+                  <a:srgbClr val="0D1B4B"/>
+                </a:solidFill>
+                <a:latin typeface="Calibri"/>
+              </a:rPr>
+              <a:t>How Zero-Shot Classification Works</a:t>
+            </a:r>
+          </a:p>
+        </p:txBody>
+      </p:sp>
+      <p:sp>
+        <p:nvSpPr>
+          <p:cNvPr id="13" name="TextBox 12"/>
+          <p:cNvSpPr txBox="1"/>
+          <p:nvPr/>
+        </p:nvSpPr>
+        <p:spPr>
+          <a:xfrm>
+            <a:off x="548640" y="4480560"/>
+            <a:ext cx="11064240" cy="1645920"/>
           </a:xfrm>
           <a:prstGeom prst="rect">
             <a:avLst/>
@@ -4042,24 +4337,51 @@
           </a:bodyPr>
           <a:lstStyle/>
           <a:p>
-            <a:pPr algn="l">
-              <a:defRPr sz="1400" b="0">
-                <a:solidFill>
-                  <a:srgbClr val="64748B"/>
-                </a:solidFill>
-                <a:latin typeface="Inter"/>
-              </a:defRPr>
-            </a:pPr>
-            <a:r>
-              <a:t>The Transformer formulates classification as a Natural Language Inference (NLI) task.</a:t>
-            </a:r>
-            <a:br/>
-            <a:r>
-              <a:t>Premise: "Apple released a new AI chip."</a:t>
-            </a:r>
-            <a:br/>
-            <a:r>
-              <a:t>Hypothesis: "This text is about Technology." -&gt; Score: 98% Entailment.</a:t>
+            <a:pPr algn="l"/>
+            <a:r>
+              <a:rPr sz="1200">
+                <a:solidFill>
+                  <a:srgbClr val="506077"/>
+                </a:solidFill>
+                <a:latin typeface="Calibri"/>
+              </a:rPr>
+              <a:t>1. Formulates classification as Natural Language Inference (NLI)</a:t>
+            </a:r>
+          </a:p>
+          <a:p>
+            <a:pPr algn="l"/>
+            <a:r>
+              <a:rPr sz="1200">
+                <a:solidFill>
+                  <a:srgbClr val="506077"/>
+                </a:solidFill>
+                <a:latin typeface="Calibri"/>
+              </a:rPr>
+              <a:t>2. Premise: "Apple released a new AI chip."</a:t>
+            </a:r>
+          </a:p>
+          <a:p>
+            <a:pPr algn="l"/>
+            <a:r>
+              <a:rPr sz="1200">
+                <a:solidFill>
+                  <a:srgbClr val="506077"/>
+                </a:solidFill>
+                <a:latin typeface="Calibri"/>
+              </a:rPr>
+              <a:t>3. Hypothesis: "This text is about Technology."</a:t>
+            </a:r>
+          </a:p>
+          <a:p>
+            <a:pPr algn="l"/>
+            <a:r>
+              <a:rPr sz="1200">
+                <a:solidFill>
+                  <a:srgbClr val="506077"/>
+                </a:solidFill>
+                <a:latin typeface="Calibri"/>
+              </a:rPr>
+              <a:t>4. Model scores: Entailment → 98%  |  Contradiction → 0.5%  →  Category = Technology ✓</a:t>
             </a:r>
           </a:p>
         </p:txBody>
@@ -4134,7 +4456,7 @@
         <p:spPr>
           <a:xfrm>
             <a:off x="0" y="0"/>
-            <a:ext cx="12191695" cy="914400"/>
+            <a:ext cx="12191695" cy="1005840"/>
           </a:xfrm>
           <a:prstGeom prst="rect">
             <a:avLst/>
@@ -4176,8 +4498,8 @@
         </p:nvSpPr>
         <p:spPr>
           <a:xfrm>
-            <a:off x="457200" y="182880"/>
-            <a:ext cx="9144000" cy="548640"/>
+            <a:off x="365760" y="182880"/>
+            <a:ext cx="8229600" cy="640080"/>
           </a:xfrm>
           <a:prstGeom prst="rect">
             <a:avLst/>
@@ -4185,20 +4507,17 @@
           <a:noFill/>
         </p:spPr>
         <p:txBody>
-          <a:bodyPr wrap="square">
-            <a:spAutoFit/>
-          </a:bodyPr>
-          <a:lstStyle/>
-          <a:p>
-            <a:pPr algn="l">
-              <a:defRPr sz="2800" b="1">
+          <a:bodyPr wrap="square"/>
+          <a:lstStyle/>
+          <a:p>
+            <a:pPr algn="l"/>
+            <a:r>
+              <a:rPr sz="2600" b="1">
                 <a:solidFill>
                   <a:srgbClr val="FFFFFF"/>
                 </a:solidFill>
-                <a:latin typeface="Inter"/>
-              </a:defRPr>
-            </a:pPr>
-            <a:r>
+                <a:latin typeface="Calibri"/>
+              </a:rPr>
               <a:t>Business Impact &amp; ROI</a:t>
             </a:r>
           </a:p>
@@ -4212,8 +4531,8 @@
         </p:nvSpPr>
         <p:spPr>
           <a:xfrm>
-            <a:off x="914400" y="1828800"/>
-            <a:ext cx="3200400" cy="1828800"/>
+            <a:off x="320040" y="1280160"/>
+            <a:ext cx="3566160" cy="2377440"/>
           </a:xfrm>
           <a:prstGeom prst="rect">
             <a:avLst/>
@@ -4221,8 +4540,10 @@
           <a:solidFill>
             <a:srgbClr val="FFFFFF"/>
           </a:solidFill>
-          <a:ln>
-            <a:noFill/>
+          <a:ln w="6350">
+            <a:solidFill>
+              <a:srgbClr val="DCE2EA"/>
+            </a:solidFill>
           </a:ln>
         </p:spPr>
         <p:style>
@@ -4255,8 +4576,8 @@
         </p:nvSpPr>
         <p:spPr>
           <a:xfrm>
-            <a:off x="1097280" y="2011680"/>
-            <a:ext cx="2743200" cy="365760"/>
+            <a:off x="502920" y="1417320"/>
+            <a:ext cx="3200400" cy="365760"/>
           </a:xfrm>
           <a:prstGeom prst="rect">
             <a:avLst/>
@@ -4264,20 +4585,17 @@
           <a:noFill/>
         </p:spPr>
         <p:txBody>
-          <a:bodyPr wrap="square">
-            <a:spAutoFit/>
-          </a:bodyPr>
-          <a:lstStyle/>
-          <a:p>
-            <a:pPr algn="l">
-              <a:defRPr sz="1600" b="0">
-                <a:solidFill>
-                  <a:srgbClr val="64748B"/>
-                </a:solidFill>
-                <a:latin typeface="Inter"/>
-              </a:defRPr>
-            </a:pPr>
-            <a:r>
+          <a:bodyPr wrap="square"/>
+          <a:lstStyle/>
+          <a:p>
+            <a:pPr algn="l"/>
+            <a:r>
+              <a:rPr sz="1400" b="0">
+                <a:solidFill>
+                  <a:srgbClr val="506077"/>
+                </a:solidFill>
+                <a:latin typeface="Calibri"/>
+              </a:rPr>
               <a:t>Scale</a:t>
             </a:r>
           </a:p>
@@ -4291,8 +4609,8 @@
         </p:nvSpPr>
         <p:spPr>
           <a:xfrm>
-            <a:off x="1097280" y="2468880"/>
-            <a:ext cx="2743200" cy="731520"/>
+            <a:off x="502920" y="1874519"/>
+            <a:ext cx="3200400" cy="822960"/>
           </a:xfrm>
           <a:prstGeom prst="rect">
             <a:avLst/>
@@ -4300,20 +4618,17 @@
           <a:noFill/>
         </p:spPr>
         <p:txBody>
-          <a:bodyPr wrap="square">
-            <a:spAutoFit/>
-          </a:bodyPr>
-          <a:lstStyle/>
-          <a:p>
-            <a:pPr algn="l">
-              <a:defRPr sz="4000" b="1">
+          <a:bodyPr wrap="square"/>
+          <a:lstStyle/>
+          <a:p>
+            <a:pPr algn="l"/>
+            <a:r>
+              <a:rPr sz="3800" b="1">
                 <a:solidFill>
                   <a:srgbClr val="0D1B4B"/>
                 </a:solidFill>
-                <a:latin typeface="Inter"/>
-              </a:defRPr>
-            </a:pPr>
-            <a:r>
+                <a:latin typeface="Calibri"/>
+              </a:rPr>
               <a:t>10,000</a:t>
             </a:r>
           </a:p>
@@ -4327,8 +4642,8 @@
         </p:nvSpPr>
         <p:spPr>
           <a:xfrm>
-            <a:off x="1097280" y="3200400"/>
-            <a:ext cx="2743200" cy="365760"/>
+            <a:off x="502920" y="2788920"/>
+            <a:ext cx="3200400" cy="365760"/>
           </a:xfrm>
           <a:prstGeom prst="rect">
             <a:avLst/>
@@ -4336,20 +4651,17 @@
           <a:noFill/>
         </p:spPr>
         <p:txBody>
-          <a:bodyPr wrap="square">
-            <a:spAutoFit/>
-          </a:bodyPr>
-          <a:lstStyle/>
-          <a:p>
-            <a:pPr algn="l">
-              <a:defRPr sz="1200" b="0">
-                <a:solidFill>
-                  <a:srgbClr val="64748B"/>
-                </a:solidFill>
-                <a:latin typeface="Inter"/>
-              </a:defRPr>
-            </a:pPr>
-            <a:r>
+          <a:bodyPr wrap="square"/>
+          <a:lstStyle/>
+          <a:p>
+            <a:pPr algn="l"/>
+            <a:r>
+              <a:rPr sz="1300" b="0">
+                <a:solidFill>
+                  <a:srgbClr val="506077"/>
+                </a:solidFill>
+                <a:latin typeface="Calibri"/>
+              </a:rPr>
               <a:t>Articles / Day</a:t>
             </a:r>
           </a:p>
@@ -4363,8 +4675,8 @@
         </p:nvSpPr>
         <p:spPr>
           <a:xfrm>
-            <a:off x="4480560" y="1828800"/>
-            <a:ext cx="3200400" cy="1828800"/>
+            <a:off x="4297680" y="1280160"/>
+            <a:ext cx="3566160" cy="2377440"/>
           </a:xfrm>
           <a:prstGeom prst="rect">
             <a:avLst/>
@@ -4372,8 +4684,10 @@
           <a:solidFill>
             <a:srgbClr val="FFFFFF"/>
           </a:solidFill>
-          <a:ln>
-            <a:noFill/>
+          <a:ln w="6350">
+            <a:solidFill>
+              <a:srgbClr val="DCE2EA"/>
+            </a:solidFill>
           </a:ln>
         </p:spPr>
         <p:style>
@@ -4406,8 +4720,8 @@
         </p:nvSpPr>
         <p:spPr>
           <a:xfrm>
-            <a:off x="4663440" y="2011680"/>
-            <a:ext cx="2743200" cy="365760"/>
+            <a:off x="4480560" y="1417320"/>
+            <a:ext cx="3200400" cy="365760"/>
           </a:xfrm>
           <a:prstGeom prst="rect">
             <a:avLst/>
@@ -4415,20 +4729,17 @@
           <a:noFill/>
         </p:spPr>
         <p:txBody>
-          <a:bodyPr wrap="square">
-            <a:spAutoFit/>
-          </a:bodyPr>
-          <a:lstStyle/>
-          <a:p>
-            <a:pPr algn="l">
-              <a:defRPr sz="1600" b="0">
-                <a:solidFill>
-                  <a:srgbClr val="64748B"/>
-                </a:solidFill>
-                <a:latin typeface="Inter"/>
-              </a:defRPr>
-            </a:pPr>
-            <a:r>
+          <a:bodyPr wrap="square"/>
+          <a:lstStyle/>
+          <a:p>
+            <a:pPr algn="l"/>
+            <a:r>
+              <a:rPr sz="1400" b="0">
+                <a:solidFill>
+                  <a:srgbClr val="506077"/>
+                </a:solidFill>
+                <a:latin typeface="Calibri"/>
+              </a:rPr>
               <a:t>Cost Reduction</a:t>
             </a:r>
           </a:p>
@@ -4442,8 +4753,8 @@
         </p:nvSpPr>
         <p:spPr>
           <a:xfrm>
-            <a:off x="4663440" y="2468880"/>
-            <a:ext cx="2743200" cy="731520"/>
+            <a:off x="4480560" y="1874519"/>
+            <a:ext cx="3200400" cy="822960"/>
           </a:xfrm>
           <a:prstGeom prst="rect">
             <a:avLst/>
@@ -4451,20 +4762,17 @@
           <a:noFill/>
         </p:spPr>
         <p:txBody>
-          <a:bodyPr wrap="square">
-            <a:spAutoFit/>
-          </a:bodyPr>
-          <a:lstStyle/>
-          <a:p>
-            <a:pPr algn="l">
-              <a:defRPr sz="4000" b="1">
+          <a:bodyPr wrap="square"/>
+          <a:lstStyle/>
+          <a:p>
+            <a:pPr algn="l"/>
+            <a:r>
+              <a:rPr sz="3800" b="1">
                 <a:solidFill>
                   <a:srgbClr val="0D1B4B"/>
                 </a:solidFill>
-                <a:latin typeface="Inter"/>
-              </a:defRPr>
-            </a:pPr>
-            <a:r>
+                <a:latin typeface="Calibri"/>
+              </a:rPr>
               <a:t>$180,000</a:t>
             </a:r>
           </a:p>
@@ -4478,8 +4786,8 @@
         </p:nvSpPr>
         <p:spPr>
           <a:xfrm>
-            <a:off x="4663440" y="3200400"/>
-            <a:ext cx="2743200" cy="365760"/>
+            <a:off x="4480560" y="2788920"/>
+            <a:ext cx="3200400" cy="365760"/>
           </a:xfrm>
           <a:prstGeom prst="rect">
             <a:avLst/>
@@ -4487,20 +4795,17 @@
           <a:noFill/>
         </p:spPr>
         <p:txBody>
-          <a:bodyPr wrap="square">
-            <a:spAutoFit/>
-          </a:bodyPr>
-          <a:lstStyle/>
-          <a:p>
-            <a:pPr algn="l">
-              <a:defRPr sz="1200" b="0">
-                <a:solidFill>
-                  <a:srgbClr val="64748B"/>
-                </a:solidFill>
-                <a:latin typeface="Inter"/>
-              </a:defRPr>
-            </a:pPr>
-            <a:r>
+          <a:bodyPr wrap="square"/>
+          <a:lstStyle/>
+          <a:p>
+            <a:pPr algn="l"/>
+            <a:r>
+              <a:rPr sz="1300" b="0">
+                <a:solidFill>
+                  <a:srgbClr val="506077"/>
+                </a:solidFill>
+                <a:latin typeface="Calibri"/>
+              </a:rPr>
               <a:t>Annual Savings</a:t>
             </a:r>
           </a:p>
@@ -4514,8 +4819,8 @@
         </p:nvSpPr>
         <p:spPr>
           <a:xfrm>
-            <a:off x="8046720" y="1828800"/>
-            <a:ext cx="3200400" cy="1828800"/>
+            <a:off x="8275320" y="1280160"/>
+            <a:ext cx="3566160" cy="2377440"/>
           </a:xfrm>
           <a:prstGeom prst="rect">
             <a:avLst/>
@@ -4523,8 +4828,10 @@
           <a:solidFill>
             <a:srgbClr val="FFFFFF"/>
           </a:solidFill>
-          <a:ln>
-            <a:noFill/>
+          <a:ln w="6350">
+            <a:solidFill>
+              <a:srgbClr val="DCE2EA"/>
+            </a:solidFill>
           </a:ln>
         </p:spPr>
         <p:style>
@@ -4557,8 +4864,8 @@
         </p:nvSpPr>
         <p:spPr>
           <a:xfrm>
-            <a:off x="8229600" y="2011680"/>
-            <a:ext cx="2743200" cy="365760"/>
+            <a:off x="8458200" y="1417320"/>
+            <a:ext cx="3200400" cy="365760"/>
           </a:xfrm>
           <a:prstGeom prst="rect">
             <a:avLst/>
@@ -4566,20 +4873,17 @@
           <a:noFill/>
         </p:spPr>
         <p:txBody>
-          <a:bodyPr wrap="square">
-            <a:spAutoFit/>
-          </a:bodyPr>
-          <a:lstStyle/>
-          <a:p>
-            <a:pPr algn="l">
-              <a:defRPr sz="1600" b="0">
-                <a:solidFill>
-                  <a:srgbClr val="64748B"/>
-                </a:solidFill>
-                <a:latin typeface="Inter"/>
-              </a:defRPr>
-            </a:pPr>
-            <a:r>
+          <a:bodyPr wrap="square"/>
+          <a:lstStyle/>
+          <a:p>
+            <a:pPr algn="l"/>
+            <a:r>
+              <a:rPr sz="1400" b="0">
+                <a:solidFill>
+                  <a:srgbClr val="506077"/>
+                </a:solidFill>
+                <a:latin typeface="Calibri"/>
+              </a:rPr>
               <a:t>Speed</a:t>
             </a:r>
           </a:p>
@@ -4593,8 +4897,8 @@
         </p:nvSpPr>
         <p:spPr>
           <a:xfrm>
-            <a:off x="8229600" y="2468880"/>
-            <a:ext cx="2743200" cy="731520"/>
+            <a:off x="8458200" y="1874519"/>
+            <a:ext cx="3200400" cy="822960"/>
           </a:xfrm>
           <a:prstGeom prst="rect">
             <a:avLst/>
@@ -4602,21 +4906,18 @@
           <a:noFill/>
         </p:spPr>
         <p:txBody>
-          <a:bodyPr wrap="square">
-            <a:spAutoFit/>
-          </a:bodyPr>
-          <a:lstStyle/>
-          <a:p>
-            <a:pPr algn="l">
-              <a:defRPr sz="4000" b="1">
+          <a:bodyPr wrap="square"/>
+          <a:lstStyle/>
+          <a:p>
+            <a:pPr algn="l"/>
+            <a:r>
+              <a:rPr sz="3800" b="1">
                 <a:solidFill>
                   <a:srgbClr val="0D1B4B"/>
                 </a:solidFill>
-                <a:latin typeface="Inter"/>
-              </a:defRPr>
-            </a:pPr>
-            <a:r>
-              <a:t>100x</a:t>
+                <a:latin typeface="Calibri"/>
+              </a:rPr>
+              <a:t>100×</a:t>
             </a:r>
           </a:p>
         </p:txBody>
@@ -4629,8 +4930,8 @@
         </p:nvSpPr>
         <p:spPr>
           <a:xfrm>
-            <a:off x="8229600" y="3200400"/>
-            <a:ext cx="2743200" cy="365760"/>
+            <a:off x="8458200" y="2788920"/>
+            <a:ext cx="3200400" cy="365760"/>
           </a:xfrm>
           <a:prstGeom prst="rect">
             <a:avLst/>
@@ -4638,20 +4939,17 @@
           <a:noFill/>
         </p:spPr>
         <p:txBody>
-          <a:bodyPr wrap="square">
-            <a:spAutoFit/>
-          </a:bodyPr>
-          <a:lstStyle/>
-          <a:p>
-            <a:pPr algn="l">
-              <a:defRPr sz="1200" b="0">
-                <a:solidFill>
-                  <a:srgbClr val="64748B"/>
-                </a:solidFill>
-                <a:latin typeface="Inter"/>
-              </a:defRPr>
-            </a:pPr>
-            <a:r>
+          <a:bodyPr wrap="square"/>
+          <a:lstStyle/>
+          <a:p>
+            <a:pPr algn="l"/>
+            <a:r>
+              <a:rPr sz="1300" b="0">
+                <a:solidFill>
+                  <a:srgbClr val="506077"/>
+                </a:solidFill>
+                <a:latin typeface="Calibri"/>
+              </a:rPr>
               <a:t>Faster than Humans</a:t>
             </a:r>
           </a:p>
@@ -4659,14 +4957,59 @@
       </p:sp>
       <p:sp>
         <p:nvSpPr>
-          <p:cNvPr id="17" name="TextBox 16"/>
+          <p:cNvPr id="17" name="Rectangle 16"/>
+          <p:cNvSpPr/>
+          <p:nvPr/>
+        </p:nvSpPr>
+        <p:spPr>
+          <a:xfrm>
+            <a:off x="320040" y="3931920"/>
+            <a:ext cx="11567160" cy="2377440"/>
+          </a:xfrm>
+          <a:prstGeom prst="rect">
+            <a:avLst/>
+          </a:prstGeom>
+          <a:solidFill>
+            <a:srgbClr val="FFFFFF"/>
+          </a:solidFill>
+          <a:ln w="6350">
+            <a:solidFill>
+              <a:srgbClr val="DCE2EA"/>
+            </a:solidFill>
+          </a:ln>
+        </p:spPr>
+        <p:style>
+          <a:lnRef idx="1">
+            <a:schemeClr val="accent1"/>
+          </a:lnRef>
+          <a:fillRef idx="3">
+            <a:schemeClr val="accent1"/>
+          </a:fillRef>
+          <a:effectRef idx="2">
+            <a:schemeClr val="accent1"/>
+          </a:effectRef>
+          <a:fontRef idx="minor">
+            <a:schemeClr val="lt1"/>
+          </a:fontRef>
+        </p:style>
+        <p:txBody>
+          <a:bodyPr rtlCol="0" anchor="ctr"/>
+          <a:lstStyle/>
+          <a:p>
+            <a:pPr algn="ctr"/>
+          </a:p>
+        </p:txBody>
+      </p:sp>
+      <p:sp>
+        <p:nvSpPr>
+          <p:cNvPr id="18" name="TextBox 17"/>
           <p:cNvSpPr txBox="1"/>
           <p:nvPr/>
         </p:nvSpPr>
         <p:spPr>
           <a:xfrm>
-            <a:off x="914400" y="5029200"/>
-            <a:ext cx="10362895" cy="914400"/>
+            <a:off x="502920" y="4069080"/>
+            <a:ext cx="10972800" cy="365760"/>
           </a:xfrm>
           <a:prstGeom prst="rect">
             <a:avLst/>
@@ -4674,21 +5017,51 @@
           <a:noFill/>
         </p:spPr>
         <p:txBody>
-          <a:bodyPr wrap="square">
-            <a:spAutoFit/>
-          </a:bodyPr>
-          <a:lstStyle/>
-          <a:p>
-            <a:pPr algn="ctr">
-              <a:defRPr sz="1800" b="0">
-                <a:solidFill>
-                  <a:srgbClr val="64748B"/>
-                </a:solidFill>
-                <a:latin typeface="Inter"/>
-              </a:defRPr>
-            </a:pPr>
-            <a:r>
-              <a:t>The transition from manual tagging to Hugging Face Transformers eliminates processing bottlenecks and drastically reduces operational costs across publishing and finance sectors.</a:t>
+          <a:bodyPr wrap="square"/>
+          <a:lstStyle/>
+          <a:p>
+            <a:pPr algn="l"/>
+            <a:r>
+              <a:rPr sz="1500" b="1">
+                <a:solidFill>
+                  <a:srgbClr val="0D1B4B"/>
+                </a:solidFill>
+                <a:latin typeface="Calibri"/>
+              </a:rPr>
+              <a:t>Key Takeaway</a:t>
+            </a:r>
+          </a:p>
+        </p:txBody>
+      </p:sp>
+      <p:sp>
+        <p:nvSpPr>
+          <p:cNvPr id="19" name="TextBox 18"/>
+          <p:cNvSpPr txBox="1"/>
+          <p:nvPr/>
+        </p:nvSpPr>
+        <p:spPr>
+          <a:xfrm>
+            <a:off x="502920" y="4526280"/>
+            <a:ext cx="11064240" cy="1463040"/>
+          </a:xfrm>
+          <a:prstGeom prst="rect">
+            <a:avLst/>
+          </a:prstGeom>
+          <a:noFill/>
+        </p:spPr>
+        <p:txBody>
+          <a:bodyPr wrap="square"/>
+          <a:lstStyle/>
+          <a:p>
+            <a:pPr algn="l"/>
+            <a:r>
+              <a:rPr sz="1300" b="0">
+                <a:solidFill>
+                  <a:srgbClr val="506077"/>
+                </a:solidFill>
+                <a:latin typeface="Calibri"/>
+              </a:rPr>
+              <a:t>Replacing manual tagging with AI Transformers eliminates processing bottlenecks, cuts annual costs by $180K, and scales to 10,000 articles / day — with no additional headcount.</a:t>
             </a:r>
           </a:p>
         </p:txBody>
@@ -4726,7 +5099,7 @@
             <a:avLst/>
           </a:prstGeom>
           <a:solidFill>
-            <a:srgbClr val="F8FAFC"/>
+            <a:srgbClr val="0D1B4B"/>
           </a:solidFill>
           <a:ln>
             <a:noFill/>
@@ -4756,20 +5129,53 @@
       </p:sp>
       <p:sp>
         <p:nvSpPr>
-          <p:cNvPr id="3" name="Rectangle 2"/>
+          <p:cNvPr id="3" name="TextBox 2"/>
+          <p:cNvSpPr txBox="1"/>
+          <p:nvPr/>
+        </p:nvSpPr>
+        <p:spPr>
+          <a:xfrm>
+            <a:off x="365760" y="274320"/>
+            <a:ext cx="10972800" cy="640080"/>
+          </a:xfrm>
+          <a:prstGeom prst="rect">
+            <a:avLst/>
+          </a:prstGeom>
+          <a:noFill/>
+        </p:spPr>
+        <p:txBody>
+          <a:bodyPr wrap="square"/>
+          <a:lstStyle/>
+          <a:p>
+            <a:pPr algn="l"/>
+            <a:r>
+              <a:rPr sz="2800" b="1">
+                <a:solidFill>
+                  <a:srgbClr val="FFFFFF"/>
+                </a:solidFill>
+                <a:latin typeface="Calibri"/>
+              </a:rPr>
+              <a:t>Project Links &amp; Resources</a:t>
+            </a:r>
+          </a:p>
+        </p:txBody>
+      </p:sp>
+      <p:sp>
+        <p:nvSpPr>
+          <p:cNvPr id="4" name="Rectangle 3"/>
           <p:cNvSpPr/>
           <p:nvPr/>
         </p:nvSpPr>
         <p:spPr>
           <a:xfrm>
-            <a:off x="0" y="0"/>
-            <a:ext cx="12191695" cy="914400"/>
+            <a:off x="4114800" y="1097280"/>
+            <a:ext cx="3962095" cy="45720"/>
           </a:xfrm>
           <a:prstGeom prst="rect">
             <a:avLst/>
           </a:prstGeom>
           <a:solidFill>
-            <a:srgbClr val="0D1B4B"/>
+            <a:srgbClr val="F5A623"/>
           </a:solidFill>
           <a:ln>
             <a:noFill/>
@@ -4799,56 +5205,20 @@
       </p:sp>
       <p:sp>
         <p:nvSpPr>
-          <p:cNvPr id="4" name="TextBox 3"/>
-          <p:cNvSpPr txBox="1"/>
-          <p:nvPr/>
-        </p:nvSpPr>
-        <p:spPr>
-          <a:xfrm>
-            <a:off x="457200" y="182880"/>
-            <a:ext cx="9144000" cy="548640"/>
-          </a:xfrm>
-          <a:prstGeom prst="rect">
-            <a:avLst/>
-          </a:prstGeom>
-          <a:noFill/>
-        </p:spPr>
-        <p:txBody>
-          <a:bodyPr wrap="square">
-            <a:spAutoFit/>
-          </a:bodyPr>
-          <a:lstStyle/>
-          <a:p>
-            <a:pPr algn="l">
-              <a:defRPr sz="2800" b="1">
-                <a:solidFill>
-                  <a:srgbClr val="FFFFFF"/>
-                </a:solidFill>
-                <a:latin typeface="Inter"/>
-              </a:defRPr>
-            </a:pPr>
-            <a:r>
-              <a:t>Project Links &amp; Resources</a:t>
-            </a:r>
-          </a:p>
-        </p:txBody>
-      </p:sp>
-      <p:sp>
-        <p:nvSpPr>
           <p:cNvPr id="5" name="Rectangle 4"/>
           <p:cNvSpPr/>
           <p:nvPr/>
         </p:nvSpPr>
         <p:spPr>
           <a:xfrm>
-            <a:off x="914400" y="1371600"/>
-            <a:ext cx="10362895" cy="4572000"/>
+            <a:off x="365760" y="1371600"/>
+            <a:ext cx="11430000" cy="2011680"/>
           </a:xfrm>
           <a:prstGeom prst="rect">
             <a:avLst/>
           </a:prstGeom>
           <a:solidFill>
-            <a:srgbClr val="FFFFFF"/>
+            <a:srgbClr val="192C64"/>
           </a:solidFill>
           <a:ln>
             <a:noFill/>
@@ -4884,8 +5254,8 @@
         </p:nvSpPr>
         <p:spPr>
           <a:xfrm>
-            <a:off x="1371600" y="1828800"/>
-            <a:ext cx="9144000" cy="457200"/>
+            <a:off x="640080" y="1508760"/>
+            <a:ext cx="10515600" cy="457200"/>
           </a:xfrm>
           <a:prstGeom prst="rect">
             <a:avLst/>
@@ -4893,21 +5263,18 @@
           <a:noFill/>
         </p:spPr>
         <p:txBody>
-          <a:bodyPr wrap="square">
-            <a:spAutoFit/>
-          </a:bodyPr>
-          <a:lstStyle/>
-          <a:p>
-            <a:pPr algn="l">
-              <a:defRPr sz="2400" b="1">
-                <a:solidFill>
-                  <a:srgbClr val="0D1B4B"/>
-                </a:solidFill>
-                <a:latin typeface="Inter"/>
-              </a:defRPr>
-            </a:pPr>
-            <a:r>
-              <a:t>Source Code (GitHub Repository)</a:t>
+          <a:bodyPr wrap="square"/>
+          <a:lstStyle/>
+          <a:p>
+            <a:pPr algn="l"/>
+            <a:r>
+              <a:rPr sz="1600" b="1">
+                <a:solidFill>
+                  <a:srgbClr val="F5A623"/>
+                </a:solidFill>
+                <a:latin typeface="Calibri"/>
+              </a:rPr>
+              <a:t>⭐  Source Code — GitHub Repository</a:t>
             </a:r>
           </a:p>
         </p:txBody>
@@ -4920,8 +5287,8 @@
         </p:nvSpPr>
         <p:spPr>
           <a:xfrm>
-            <a:off x="1371600" y="2468880"/>
-            <a:ext cx="9144000" cy="457200"/>
+            <a:off x="640080" y="2011680"/>
+            <a:ext cx="10515600" cy="457200"/>
           </a:xfrm>
           <a:prstGeom prst="rect">
             <a:avLst/>
@@ -4929,20 +5296,17 @@
           <a:noFill/>
         </p:spPr>
         <p:txBody>
-          <a:bodyPr wrap="square">
-            <a:spAutoFit/>
-          </a:bodyPr>
-          <a:lstStyle/>
-          <a:p>
-            <a:pPr algn="l">
-              <a:defRPr sz="2000" b="0">
-                <a:solidFill>
-                  <a:srgbClr val="64748B"/>
-                </a:solidFill>
-                <a:latin typeface="Inter"/>
-              </a:defRPr>
-            </a:pPr>
-            <a:r>
+          <a:bodyPr wrap="square"/>
+          <a:lstStyle/>
+          <a:p>
+            <a:pPr algn="l"/>
+            <a:r>
+              <a:rPr sz="1600" b="0">
+                <a:solidFill>
+                  <a:srgbClr val="FFFFFF"/>
+                </a:solidFill>
+                <a:latin typeface="Calibri"/>
+              </a:rPr>
               <a:t>https://github.com/gy22122004-forge/News-Classification</a:t>
             </a:r>
           </a:p>
@@ -4950,37 +5314,44 @@
       </p:sp>
       <p:sp>
         <p:nvSpPr>
-          <p:cNvPr id="8" name="TextBox 7"/>
-          <p:cNvSpPr txBox="1"/>
+          <p:cNvPr id="8" name="Rectangle 7"/>
+          <p:cNvSpPr/>
           <p:nvPr/>
         </p:nvSpPr>
         <p:spPr>
           <a:xfrm>
-            <a:off x="1371600" y="3657600"/>
-            <a:ext cx="9144000" cy="457200"/>
-          </a:xfrm>
-          <a:prstGeom prst="rect">
-            <a:avLst/>
-          </a:prstGeom>
-          <a:noFill/>
-        </p:spPr>
-        <p:txBody>
-          <a:bodyPr wrap="square">
-            <a:spAutoFit/>
-          </a:bodyPr>
-          <a:lstStyle/>
-          <a:p>
-            <a:pPr algn="l">
-              <a:defRPr sz="2400" b="1">
-                <a:solidFill>
-                  <a:srgbClr val="0D1B4B"/>
-                </a:solidFill>
-                <a:latin typeface="Inter"/>
-              </a:defRPr>
-            </a:pPr>
-            <a:r>
-              <a:t>Live AI Demo (Deployment URL)</a:t>
-            </a:r>
+            <a:off x="365760" y="3566160"/>
+            <a:ext cx="11430000" cy="2011680"/>
+          </a:xfrm>
+          <a:prstGeom prst="rect">
+            <a:avLst/>
+          </a:prstGeom>
+          <a:solidFill>
+            <a:srgbClr val="192C64"/>
+          </a:solidFill>
+          <a:ln>
+            <a:noFill/>
+          </a:ln>
+        </p:spPr>
+        <p:style>
+          <a:lnRef idx="1">
+            <a:schemeClr val="accent1"/>
+          </a:lnRef>
+          <a:fillRef idx="3">
+            <a:schemeClr val="accent1"/>
+          </a:fillRef>
+          <a:effectRef idx="2">
+            <a:schemeClr val="accent1"/>
+          </a:effectRef>
+          <a:fontRef idx="minor">
+            <a:schemeClr val="lt1"/>
+          </a:fontRef>
+        </p:style>
+        <p:txBody>
+          <a:bodyPr rtlCol="0" anchor="ctr"/>
+          <a:lstStyle/>
+          <a:p>
+            <a:pPr algn="ctr"/>
           </a:p>
         </p:txBody>
       </p:sp>
@@ -4992,8 +5363,8 @@
         </p:nvSpPr>
         <p:spPr>
           <a:xfrm>
-            <a:off x="1371600" y="4297680"/>
-            <a:ext cx="9144000" cy="457200"/>
+            <a:off x="640080" y="3703320"/>
+            <a:ext cx="10515600" cy="457200"/>
           </a:xfrm>
           <a:prstGeom prst="rect">
             <a:avLst/>
@@ -5001,21 +5372,84 @@
           <a:noFill/>
         </p:spPr>
         <p:txBody>
-          <a:bodyPr wrap="square">
-            <a:spAutoFit/>
-          </a:bodyPr>
-          <a:lstStyle/>
-          <a:p>
-            <a:pPr algn="l">
-              <a:defRPr sz="2000" b="0">
-                <a:solidFill>
-                  <a:srgbClr val="64748B"/>
-                </a:solidFill>
-                <a:latin typeface="Inter"/>
-              </a:defRPr>
-            </a:pPr>
-            <a:r>
+          <a:bodyPr wrap="square"/>
+          <a:lstStyle/>
+          <a:p>
+            <a:pPr algn="l"/>
+            <a:r>
+              <a:rPr sz="1600" b="1">
+                <a:solidFill>
+                  <a:srgbClr val="F5A623"/>
+                </a:solidFill>
+                <a:latin typeface="Calibri"/>
+              </a:rPr>
+              <a:t>🚀  Live AI Demo — Deployed App</a:t>
+            </a:r>
+          </a:p>
+        </p:txBody>
+      </p:sp>
+      <p:sp>
+        <p:nvSpPr>
+          <p:cNvPr id="10" name="TextBox 9"/>
+          <p:cNvSpPr txBox="1"/>
+          <p:nvPr/>
+        </p:nvSpPr>
+        <p:spPr>
+          <a:xfrm>
+            <a:off x="640080" y="4206240"/>
+            <a:ext cx="10515600" cy="457200"/>
+          </a:xfrm>
+          <a:prstGeom prst="rect">
+            <a:avLst/>
+          </a:prstGeom>
+          <a:noFill/>
+        </p:spPr>
+        <p:txBody>
+          <a:bodyPr wrap="square"/>
+          <a:lstStyle/>
+          <a:p>
+            <a:pPr algn="l"/>
+            <a:r>
+              <a:rPr sz="1600" b="0">
+                <a:solidFill>
+                  <a:srgbClr val="FFFFFF"/>
+                </a:solidFill>
+                <a:latin typeface="Calibri"/>
+              </a:rPr>
               <a:t>https://ai-news-classifier-gaurav.loca.lt</a:t>
+            </a:r>
+          </a:p>
+        </p:txBody>
+      </p:sp>
+      <p:sp>
+        <p:nvSpPr>
+          <p:cNvPr id="11" name="TextBox 10"/>
+          <p:cNvSpPr txBox="1"/>
+          <p:nvPr/>
+        </p:nvSpPr>
+        <p:spPr>
+          <a:xfrm>
+            <a:off x="0" y="6309360"/>
+            <a:ext cx="12191695" cy="365760"/>
+          </a:xfrm>
+          <a:prstGeom prst="rect">
+            <a:avLst/>
+          </a:prstGeom>
+          <a:noFill/>
+        </p:spPr>
+        <p:txBody>
+          <a:bodyPr wrap="square"/>
+          <a:lstStyle/>
+          <a:p>
+            <a:pPr algn="ctr"/>
+            <a:r>
+              <a:rPr sz="1200" b="0">
+                <a:solidFill>
+                  <a:srgbClr val="F5A623"/>
+                </a:solidFill>
+                <a:latin typeface="Calibri"/>
+              </a:rPr>
+              <a:t>Prepared by Gaurav Yadav</a:t>
             </a:r>
           </a:p>
         </p:txBody>

</xml_diff>